<commit_message>
Submission: real screenshots in the deck, fix the hackathon name
- Deck slide 8 now shows real screenshots of both apps running on the
  synthetic demo data (staff dashboard + marketplace home), captured
  from the live dev servers. submission/screenshots/ has these plus the
  discovery / ranking-rubric / case-file / marketplace-login views.
- Corrected the event name everywhere: it's "the first Alibaba Cloud AI
  Hackathon in Pakistan, hosted by Al-Khidmat Foundation" — not
  "Alibaba x GitHub". Fixed in CLAUDE.md, the deck (title, footers,
  close) and PROJECT_SUMMARY.md.
- Reworded slide 8 ("The staff portal and the marketplace app", not
  "It's built - not mocked") and slide 6 ("The confidence model /
  One measurable job, done carefully").

Co-Authored-By: Claude Sonnet 5 <noreply@anthropic.com>
</commit_message>
<xml_diff>
--- a/submission/Mustahiq_AI_Presentation.pptx
+++ b/submission/Mustahiq_AI_Presentation.pptx
@@ -3225,7 +3225,7 @@
                 <a:ea typeface="Inter"/>
                 <a:cs typeface="Inter"/>
               </a:rPr>
-              <a:t>AL-KHIDMAT FOUNDATION  ·  ALIBABA  ·  GITHUB</a:t>
+              <a:t>ALIBABA CLOUD AI HACKATHON  ·  HOSTED BY AL-KHIDMAT FOUNDATION</a:t>
             </a:r>
           </a:p>
         </p:txBody>
@@ -3412,7 +3412,7 @@
                 <a:ea typeface="Inter"/>
                 <a:cs typeface="Inter"/>
               </a:rPr>
-              <a:t>Team submission  ·  built on free infrastructure  ·  everything shown is real and running</a:t>
+              <a:t>A team submission  ·  built end to end on free-tier infrastructure</a:t>
             </a:r>
           </a:p>
         </p:txBody>
@@ -4284,7 +4284,7 @@
                 <a:ea typeface="Inter"/>
                 <a:cs typeface="Inter"/>
               </a:rPr>
-              <a:t>Mustahiq AI  ·  Al-Khidmat × Alibaba × GitHub hackathon</a:t>
+              <a:t>Mustahiq AI  ·  Alibaba Cloud AI Hackathon  ·  hosted by Al-Khidmat Foundation</a:t>
             </a:r>
           </a:p>
         </p:txBody>
@@ -5126,7 +5126,7 @@
                 <a:ea typeface="Inter"/>
                 <a:cs typeface="Inter"/>
               </a:rPr>
-              <a:t>Mustahiq AI  ·  Al-Khidmat × Alibaba × GitHub hackathon prototype</a:t>
+              <a:t>Mustahiq AI  ·  Alibaba Cloud AI Hackathon  ·  hosted by Al-Khidmat Foundation</a:t>
             </a:r>
           </a:p>
         </p:txBody>
@@ -6052,7 +6052,7 @@
                 <a:ea typeface="Inter"/>
                 <a:cs typeface="Inter"/>
               </a:rPr>
-              <a:t>Mustahiq AI  ·  Al-Khidmat × Alibaba × GitHub hackathon prototype</a:t>
+              <a:t>Mustahiq AI  ·  Alibaba Cloud AI Hackathon  ·  hosted by Al-Khidmat Foundation</a:t>
             </a:r>
           </a:p>
         </p:txBody>
@@ -7214,7 +7214,7 @@
                 <a:ea typeface="Inter"/>
                 <a:cs typeface="Inter"/>
               </a:rPr>
-              <a:t>Mustahiq AI  ·  Al-Khidmat × Alibaba × GitHub hackathon prototype</a:t>
+              <a:t>Mustahiq AI  ·  Alibaba Cloud AI Hackathon  ·  hosted by Al-Khidmat Foundation</a:t>
             </a:r>
           </a:p>
         </p:txBody>
@@ -8440,7 +8440,7 @@
                 <a:ea typeface="Inter"/>
                 <a:cs typeface="Inter"/>
               </a:rPr>
-              <a:t>Mustahiq AI  ·  Al-Khidmat × Alibaba × GitHub hackathon prototype</a:t>
+              <a:t>Mustahiq AI  ·  Alibaba Cloud AI Hackathon  ·  hosted by Al-Khidmat Foundation</a:t>
             </a:r>
           </a:p>
         </p:txBody>
@@ -8590,7 +8590,7 @@
                 <a:ea typeface="Inter"/>
                 <a:cs typeface="Inter"/>
               </a:rPr>
-              <a:t>THE AI, HONESTLY</a:t>
+              <a:t>THE CONFIDENCE MODEL</a:t>
             </a:r>
           </a:p>
         </p:txBody>
@@ -8634,7 +8634,7 @@
                 <a:ea typeface="Poppins"/>
                 <a:cs typeface="Poppins"/>
               </a:rPr>
-              <a:t>Calibrated, auditable, deliberately narrow</a:t>
+              <a:t>One measurable job, done carefully</a:t>
             </a:r>
           </a:p>
         </p:txBody>
@@ -10489,7 +10489,7 @@
                 <a:ea typeface="Inter"/>
                 <a:cs typeface="Inter"/>
               </a:rPr>
-              <a:t>Mustahiq AI  ·  Al-Khidmat × Alibaba × GitHub hackathon prototype</a:t>
+              <a:t>Mustahiq AI  ·  Alibaba Cloud AI Hackathon  ·  hosted by Al-Khidmat Foundation</a:t>
             </a:r>
           </a:p>
         </p:txBody>
@@ -10727,7 +10727,7 @@
                 <a:ea typeface="Poppins"/>
                 <a:cs typeface="Poppins"/>
               </a:rPr>
-              <a:t>It's built — not mocked</a:t>
+              <a:t>The staff portal and the marketplace app</a:t>
             </a:r>
           </a:p>
         </p:txBody>
@@ -10771,25 +10771,69 @@
                 <a:ea typeface="Inter"/>
                 <a:cs typeface="Inter"/>
               </a:rPr>
-              <a:t>Both web apps, the API, the engine and the full workflow run today.</a:t>
-            </a:r>
-          </a:p>
-        </p:txBody>
-      </p:sp>
-      <p:sp>
-        <p:nvSpPr>
-          <p:cNvPr id="7" name="Rounded Rectangle 6"/>
+              <a:t>Two web apps over one API and engine. Every screen here is running on synthetic demo data.</a:t>
+            </a:r>
+          </a:p>
+        </p:txBody>
+      </p:sp>
+      <p:sp>
+        <p:nvSpPr>
+          <p:cNvPr id="7" name="TextBox 6"/>
+          <p:cNvSpPr txBox="1"/>
+          <p:nvPr/>
+        </p:nvSpPr>
+        <p:spPr>
+          <a:xfrm>
+            <a:off x="868680" y="2011680"/>
+            <a:ext cx="6400800" cy="320040"/>
+          </a:xfrm>
+          <a:prstGeom prst="rect">
+            <a:avLst/>
+          </a:prstGeom>
+          <a:noFill/>
+        </p:spPr>
+        <p:txBody>
+          <a:bodyPr wrap="square" anchor="t">
+            <a:spAutoFit/>
+          </a:bodyPr>
+          <a:lstStyle/>
+          <a:p>
+            <a:pPr algn="l">
+              <a:lnSpc>
+                <a:spcPct val="112000"/>
+              </a:lnSpc>
+              <a:spcAft>
+                <a:spcPts val="600"/>
+              </a:spcAft>
+            </a:pPr>
+            <a:r>
+              <a:rPr sz="1100" b="1">
+                <a:solidFill>
+                  <a:srgbClr val="0060AE"/>
+                </a:solidFill>
+                <a:latin typeface="Inter"/>
+                <a:ea typeface="Inter"/>
+                <a:cs typeface="Inter"/>
+              </a:rPr>
+              <a:t>STAFF PORTAL  ·  overview</a:t>
+            </a:r>
+          </a:p>
+        </p:txBody>
+      </p:sp>
+      <p:sp>
+        <p:nvSpPr>
+          <p:cNvPr id="8" name="Rounded Rectangle 7"/>
           <p:cNvSpPr/>
           <p:nvPr/>
         </p:nvSpPr>
         <p:spPr>
           <a:xfrm>
-            <a:off x="822960" y="1965960"/>
-            <a:ext cx="5257800" cy="3566160"/>
+            <a:off x="768096" y="2322576"/>
+            <a:ext cx="7424927" cy="3493008"/>
           </a:xfrm>
           <a:prstGeom prst="roundRect">
             <a:avLst>
-              <a:gd name="adj" fmla="val 8000"/>
+              <a:gd name="adj" fmla="val 4000"/>
             </a:avLst>
           </a:prstGeom>
           <a:solidFill>
@@ -10817,66 +10861,95 @@
           </a:fontRef>
         </p:style>
         <p:txBody>
-          <a:bodyPr rtlCol="0" anchor="t" wrap="square" lIns="164592" rIns="164592" tIns="146304" bIns="146304"/>
-          <a:lstStyle/>
-          <a:p>
-            <a:pPr algn="l">
-              <a:lnSpc>
-                <a:spcPct val="110000"/>
-              </a:lnSpc>
-              <a:spcAft>
-                <a:spcPts val="300"/>
-              </a:spcAft>
-            </a:pPr>
-            <a:r>
-              <a:rPr sz="1300" b="1">
-                <a:solidFill>
-                  <a:srgbClr val="0060AE"/>
-                </a:solidFill>
-                <a:latin typeface="Inter"/>
-                <a:ea typeface="Inter"/>
-                <a:cs typeface="Inter"/>
-              </a:rPr>
-              <a:t>STAFF PORTAL</a:t>
-            </a:r>
-          </a:p>
-          <a:p>
-            <a:pPr algn="l">
-              <a:lnSpc>
-                <a:spcPct val="110000"/>
-              </a:lnSpc>
-              <a:spcAft>
-                <a:spcPts val="300"/>
-              </a:spcAft>
-            </a:pPr>
-            <a:r>
-              <a:rPr sz="1100" b="0">
-                <a:solidFill>
-                  <a:srgbClr val="24384B"/>
-                </a:solidFill>
-                <a:latin typeface="Inter"/>
-                <a:ea typeface="Inter"/>
-                <a:cs typeface="Inter"/>
-              </a:rPr>
-              <a:t>Register  →  discovery worklist  →  outreach  →  verification  →  ranked candidate pool  →  allocation  →  department reports</a:t>
-            </a:r>
-          </a:p>
-        </p:txBody>
-      </p:sp>
-      <p:sp>
-        <p:nvSpPr>
-          <p:cNvPr id="8" name="Rounded Rectangle 7"/>
+          <a:bodyPr rtlCol="0" anchor="ctr"/>
+          <a:lstStyle/>
+          <a:p>
+            <a:pPr algn="ctr"/>
+          </a:p>
+        </p:txBody>
+      </p:sp>
+      <p:pic>
+        <p:nvPicPr>
+          <p:cNvPr id="9" name="Picture 8" descr="staff-dashboard.png"/>
+          <p:cNvPicPr>
+            <a:picLocks noChangeAspect="1"/>
+          </p:cNvPicPr>
+          <p:nvPr/>
+        </p:nvPicPr>
+        <p:blipFill>
+          <a:blip r:embed="rId2"/>
+          <a:stretch>
+            <a:fillRect/>
+          </a:stretch>
+        </p:blipFill>
+        <p:spPr>
+          <a:xfrm>
+            <a:off x="822960" y="2377440"/>
+            <a:ext cx="7315200" cy="3383280"/>
+          </a:xfrm>
+          <a:prstGeom prst="rect">
+            <a:avLst/>
+          </a:prstGeom>
+        </p:spPr>
+      </p:pic>
+      <p:sp>
+        <p:nvSpPr>
+          <p:cNvPr id="10" name="TextBox 9"/>
+          <p:cNvSpPr txBox="1"/>
+          <p:nvPr/>
+        </p:nvSpPr>
+        <p:spPr>
+          <a:xfrm>
+            <a:off x="8549640" y="2011680"/>
+            <a:ext cx="3017520" cy="320040"/>
+          </a:xfrm>
+          <a:prstGeom prst="rect">
+            <a:avLst/>
+          </a:prstGeom>
+          <a:noFill/>
+        </p:spPr>
+        <p:txBody>
+          <a:bodyPr wrap="square" anchor="t">
+            <a:spAutoFit/>
+          </a:bodyPr>
+          <a:lstStyle/>
+          <a:p>
+            <a:pPr algn="l">
+              <a:lnSpc>
+                <a:spcPct val="112000"/>
+              </a:lnSpc>
+              <a:spcAft>
+                <a:spcPts val="600"/>
+              </a:spcAft>
+            </a:pPr>
+            <a:r>
+              <a:rPr sz="1100" b="1">
+                <a:solidFill>
+                  <a:srgbClr val="5AA632"/>
+                </a:solidFill>
+                <a:latin typeface="Inter"/>
+                <a:ea typeface="Inter"/>
+                <a:cs typeface="Inter"/>
+              </a:rPr>
+              <a:t>MARKETPLACE APP</a:t>
+            </a:r>
+          </a:p>
+        </p:txBody>
+      </p:sp>
+      <p:sp>
+        <p:nvSpPr>
+          <p:cNvPr id="11" name="Rounded Rectangle 10"/>
           <p:cNvSpPr/>
           <p:nvPr/>
         </p:nvSpPr>
         <p:spPr>
           <a:xfrm>
-            <a:off x="6355080" y="1965960"/>
-            <a:ext cx="5029200" cy="3566160"/>
+            <a:off x="8494776" y="2322576"/>
+            <a:ext cx="2441448" cy="3675887"/>
           </a:xfrm>
           <a:prstGeom prst="roundRect">
             <a:avLst>
-              <a:gd name="adj" fmla="val 8000"/>
+              <a:gd name="adj" fmla="val 4000"/>
             </a:avLst>
           </a:prstGeom>
           <a:solidFill>
@@ -10904,193 +10977,46 @@
           </a:fontRef>
         </p:style>
         <p:txBody>
-          <a:bodyPr rtlCol="0" anchor="t" wrap="square" lIns="164592" rIns="164592" tIns="146304" bIns="146304"/>
-          <a:lstStyle/>
-          <a:p>
-            <a:pPr algn="l">
-              <a:lnSpc>
-                <a:spcPct val="110000"/>
-              </a:lnSpc>
-              <a:spcAft>
-                <a:spcPts val="300"/>
-              </a:spcAft>
-            </a:pPr>
-            <a:r>
-              <a:rPr sz="1300" b="1">
-                <a:solidFill>
-                  <a:srgbClr val="5AA632"/>
-                </a:solidFill>
-                <a:latin typeface="Inter"/>
-                <a:ea typeface="Inter"/>
-                <a:cs typeface="Inter"/>
-              </a:rPr>
-              <a:t>MARKETPLACE APP</a:t>
-            </a:r>
-          </a:p>
-          <a:p>
-            <a:pPr algn="l">
-              <a:lnSpc>
-                <a:spcPct val="110000"/>
-              </a:lnSpc>
-              <a:spcAft>
-                <a:spcPts val="300"/>
-              </a:spcAft>
-            </a:pPr>
-            <a:r>
-              <a:rPr sz="1100" b="0">
-                <a:solidFill>
-                  <a:srgbClr val="24384B"/>
-                </a:solidFill>
-                <a:latin typeface="Inter"/>
-                <a:ea typeface="Inter"/>
-                <a:cs typeface="Inter"/>
-              </a:rPr>
-              <a:t>Phone + SMS-code login  →  voice / text listing  →  review  →  match results  →  in-app chat to arrange details</a:t>
-            </a:r>
-          </a:p>
-        </p:txBody>
-      </p:sp>
-      <p:sp>
-        <p:nvSpPr>
-          <p:cNvPr id="9" name="Rounded Rectangle 8"/>
-          <p:cNvSpPr/>
-          <p:nvPr/>
-        </p:nvSpPr>
-        <p:spPr>
-          <a:xfrm>
-            <a:off x="1051560" y="3017520"/>
-            <a:ext cx="4800600" cy="2331720"/>
-          </a:xfrm>
-          <a:prstGeom prst="roundRect">
-            <a:avLst>
-              <a:gd name="adj" fmla="val 8000"/>
-            </a:avLst>
-          </a:prstGeom>
-          <a:solidFill>
-            <a:srgbClr val="EEF2F7"/>
-          </a:solidFill>
-          <a:ln w="12700">
-            <a:solidFill>
-              <a:srgbClr val="D9E2EC"/>
-            </a:solidFill>
-          </a:ln>
-          <a:effectLst/>
-        </p:spPr>
-        <p:style>
-          <a:lnRef idx="1">
-            <a:schemeClr val="accent1"/>
-          </a:lnRef>
-          <a:fillRef idx="3">
-            <a:schemeClr val="accent1"/>
-          </a:fillRef>
-          <a:effectRef idx="2">
-            <a:schemeClr val="accent1"/>
-          </a:effectRef>
-          <a:fontRef idx="minor">
-            <a:schemeClr val="lt1"/>
-          </a:fontRef>
-        </p:style>
-        <p:txBody>
-          <a:bodyPr rtlCol="0" anchor="ctr" wrap="square" lIns="164592" rIns="164592" tIns="146304" bIns="146304"/>
-          <a:lstStyle/>
-          <a:p>
-            <a:pPr algn="ctr">
-              <a:lnSpc>
-                <a:spcPct val="110000"/>
-              </a:lnSpc>
-              <a:spcAft>
-                <a:spcPts val="300"/>
-              </a:spcAft>
-            </a:pPr>
-            <a:r>
-              <a:rPr sz="1000" b="1">
-                <a:solidFill>
-                  <a:srgbClr val="738294"/>
-                </a:solidFill>
-                <a:latin typeface="Inter"/>
-                <a:ea typeface="Inter"/>
-                <a:cs typeface="Inter"/>
-              </a:rPr>
-              <a:t>add screenshot:  staff dashboard</a:t>
-            </a:r>
-          </a:p>
-        </p:txBody>
-      </p:sp>
-      <p:sp>
-        <p:nvSpPr>
-          <p:cNvPr id="10" name="Rounded Rectangle 9"/>
-          <p:cNvSpPr/>
-          <p:nvPr/>
-        </p:nvSpPr>
-        <p:spPr>
-          <a:xfrm>
-            <a:off x="6583680" y="3017520"/>
-            <a:ext cx="4572000" cy="2331720"/>
-          </a:xfrm>
-          <a:prstGeom prst="roundRect">
-            <a:avLst>
-              <a:gd name="adj" fmla="val 8000"/>
-            </a:avLst>
-          </a:prstGeom>
-          <a:solidFill>
-            <a:srgbClr val="EEF2F7"/>
-          </a:solidFill>
-          <a:ln w="12700">
-            <a:solidFill>
-              <a:srgbClr val="D9E2EC"/>
-            </a:solidFill>
-          </a:ln>
-          <a:effectLst/>
-        </p:spPr>
-        <p:style>
-          <a:lnRef idx="1">
-            <a:schemeClr val="accent1"/>
-          </a:lnRef>
-          <a:fillRef idx="3">
-            <a:schemeClr val="accent1"/>
-          </a:fillRef>
-          <a:effectRef idx="2">
-            <a:schemeClr val="accent1"/>
-          </a:effectRef>
-          <a:fontRef idx="minor">
-            <a:schemeClr val="lt1"/>
-          </a:fontRef>
-        </p:style>
-        <p:txBody>
-          <a:bodyPr rtlCol="0" anchor="ctr" wrap="square" lIns="164592" rIns="164592" tIns="146304" bIns="146304"/>
-          <a:lstStyle/>
-          <a:p>
-            <a:pPr algn="ctr">
-              <a:lnSpc>
-                <a:spcPct val="110000"/>
-              </a:lnSpc>
-              <a:spcAft>
-                <a:spcPts val="300"/>
-              </a:spcAft>
-            </a:pPr>
-            <a:r>
-              <a:rPr sz="1000" b="1">
-                <a:solidFill>
-                  <a:srgbClr val="738294"/>
-                </a:solidFill>
-                <a:latin typeface="Inter"/>
-                <a:ea typeface="Inter"/>
-                <a:cs typeface="Inter"/>
-              </a:rPr>
-              <a:t>add screenshot:  match results</a:t>
-            </a:r>
-          </a:p>
-        </p:txBody>
-      </p:sp>
-      <p:sp>
-        <p:nvSpPr>
-          <p:cNvPr id="11" name="TextBox 10"/>
+          <a:bodyPr rtlCol="0" anchor="ctr"/>
+          <a:lstStyle/>
+          <a:p>
+            <a:pPr algn="ctr"/>
+          </a:p>
+        </p:txBody>
+      </p:sp>
+      <p:pic>
+        <p:nvPicPr>
+          <p:cNvPr id="12" name="Picture 11" descr="market-home.png"/>
+          <p:cNvPicPr>
+            <a:picLocks noChangeAspect="1"/>
+          </p:cNvPicPr>
+          <p:nvPr/>
+        </p:nvPicPr>
+        <p:blipFill>
+          <a:blip r:embed="rId3"/>
+          <a:stretch>
+            <a:fillRect/>
+          </a:stretch>
+        </p:blipFill>
+        <p:spPr>
+          <a:xfrm>
+            <a:off x="8549640" y="2377440"/>
+            <a:ext cx="2331720" cy="3566160"/>
+          </a:xfrm>
+          <a:prstGeom prst="rect">
+            <a:avLst/>
+          </a:prstGeom>
+        </p:spPr>
+      </p:pic>
+      <p:sp>
+        <p:nvSpPr>
+          <p:cNvPr id="13" name="TextBox 12"/>
           <p:cNvSpPr txBox="1"/>
           <p:nvPr/>
         </p:nvSpPr>
         <p:spPr>
           <a:xfrm>
-            <a:off x="841248" y="5760720"/>
+            <a:off x="841248" y="6053328"/>
             <a:ext cx="10515600" cy="457200"/>
           </a:xfrm>
           <a:prstGeom prst="rect">
@@ -11121,14 +11047,14 @@
                 <a:ea typeface="Inter"/>
                 <a:cs typeface="Inter"/>
               </a:rPr>
-              <a:t>Tested end to end — 41 eligibility tests, 33 staff-workflow tests, marketplace smoke tests, all green.</a:t>
-            </a:r>
-          </a:p>
-        </p:txBody>
-      </p:sp>
-      <p:sp>
-        <p:nvSpPr>
-          <p:cNvPr id="12" name="TextBox 11"/>
+              <a:t>Built end to end and tested — 41 eligibility tests, 33 staff-workflow tests, plus marketplace smoke tests.</a:t>
+            </a:r>
+          </a:p>
+        </p:txBody>
+      </p:sp>
+      <p:sp>
+        <p:nvSpPr>
+          <p:cNvPr id="14" name="TextBox 13"/>
           <p:cNvSpPr txBox="1"/>
           <p:nvPr/>
         </p:nvSpPr>
@@ -11165,14 +11091,14 @@
                 <a:ea typeface="Inter"/>
                 <a:cs typeface="Inter"/>
               </a:rPr>
-              <a:t>Mustahiq AI  ·  Al-Khidmat × Alibaba × GitHub hackathon prototype</a:t>
-            </a:r>
-          </a:p>
-        </p:txBody>
-      </p:sp>
-      <p:sp>
-        <p:nvSpPr>
-          <p:cNvPr id="13" name="TextBox 12"/>
+              <a:t>Mustahiq AI  ·  Alibaba Cloud AI Hackathon  ·  hosted by Al-Khidmat Foundation</a:t>
+            </a:r>
+          </a:p>
+        </p:txBody>
+      </p:sp>
+      <p:sp>
+        <p:nvSpPr>
+          <p:cNvPr id="15" name="TextBox 14"/>
           <p:cNvSpPr txBox="1"/>
           <p:nvPr/>
         </p:nvSpPr>
@@ -11969,7 +11895,7 @@
                 <a:ea typeface="Inter"/>
                 <a:cs typeface="Inter"/>
               </a:rPr>
-              <a:t>Mustahiq AI  ·  Al-Khidmat × Alibaba × GitHub hackathon prototype</a:t>
+              <a:t>Mustahiq AI  ·  Alibaba Cloud AI Hackathon  ·  hosted by Al-Khidmat Foundation</a:t>
             </a:r>
           </a:p>
         </p:txBody>

</xml_diff>

<commit_message>
Deck: reframe slides 2 and 10 — value, not a critique of Al-Khidmat
Slide 2 no longer asserts how Al-Khidmat currently operates ("checks one
programme per visit", "spreadsheets and memory"). It now frames the
universal hard questions of allocating limited aid, with an explicit
"not a comment on any organisation" line.

Slide 10 drops the before/after table (the "before" column read as
telling Al-Khidmat their process is broken, in front of Al-Khidmat).
It now states what the platform ADDS on top of the existing process,
and ends: "It informs the decision — it does not make it. Staff verify,
staff rank-review, staff allocate."

Slide 6 title softened; slide 11 close reworded.
</commit_message>
<xml_diff>
--- a/submission/Mustahiq_AI_Presentation.pptx
+++ b/submission/Mustahiq_AI_Presentation.pptx
@@ -3518,7 +3518,7 @@
                 <a:ea typeface="Inter"/>
                 <a:cs typeface="Inter"/>
               </a:rPr>
-              <a:t>WHAT CHANGES FOR AL-KHIDMAT</a:t>
+              <a:t>THE VALUE IT ADDS</a:t>
             </a:r>
           </a:p>
         </p:txBody>
@@ -3562,21 +3562,85 @@
                 <a:ea typeface="Poppins"/>
                 <a:cs typeface="Poppins"/>
               </a:rPr>
-              <a:t>Faster, consistent, defensible aid — and a path to self-reliance</a:t>
-            </a:r>
-          </a:p>
-        </p:txBody>
-      </p:sp>
-      <p:sp>
-        <p:nvSpPr>
-          <p:cNvPr id="5" name="TextBox 4"/>
+              <a:t>What Mustahiq AI puts on top of the existing process</a:t>
+            </a:r>
+          </a:p>
+        </p:txBody>
+      </p:sp>
+      <p:sp>
+        <p:nvSpPr>
+          <p:cNvPr id="5" name="Rounded Rectangle 4"/>
+          <p:cNvSpPr/>
+          <p:nvPr/>
+        </p:nvSpPr>
+        <p:spPr>
+          <a:xfrm>
+            <a:off x="822960" y="2148840"/>
+            <a:ext cx="457200" cy="457200"/>
+          </a:xfrm>
+          <a:prstGeom prst="roundRect">
+            <a:avLst>
+              <a:gd name="adj" fmla="val 25000"/>
+            </a:avLst>
+          </a:prstGeom>
+          <a:solidFill>
+            <a:srgbClr val="2F7A44"/>
+          </a:solidFill>
+          <a:ln>
+            <a:noFill/>
+          </a:ln>
+          <a:effectLst/>
+        </p:spPr>
+        <p:style>
+          <a:lnRef idx="1">
+            <a:schemeClr val="accent1"/>
+          </a:lnRef>
+          <a:fillRef idx="3">
+            <a:schemeClr val="accent1"/>
+          </a:fillRef>
+          <a:effectRef idx="2">
+            <a:schemeClr val="accent1"/>
+          </a:effectRef>
+          <a:fontRef idx="minor">
+            <a:schemeClr val="lt1"/>
+          </a:fontRef>
+        </p:style>
+        <p:txBody>
+          <a:bodyPr rtlCol="0" anchor="ctr" wrap="square" lIns="164592" rIns="164592" tIns="146304" bIns="146304"/>
+          <a:lstStyle/>
+          <a:p>
+            <a:pPr algn="ctr">
+              <a:lnSpc>
+                <a:spcPct val="110000"/>
+              </a:lnSpc>
+              <a:spcAft>
+                <a:spcPts val="300"/>
+              </a:spcAft>
+            </a:pPr>
+            <a:r>
+              <a:rPr sz="2000" b="1">
+                <a:solidFill>
+                  <a:srgbClr val="FFFFFF"/>
+                </a:solidFill>
+                <a:latin typeface="Inter"/>
+                <a:ea typeface="Inter"/>
+                <a:cs typeface="Inter"/>
+              </a:rPr>
+              <a:t>+</a:t>
+            </a:r>
+          </a:p>
+        </p:txBody>
+      </p:sp>
+      <p:sp>
+        <p:nvSpPr>
+          <p:cNvPr id="6" name="TextBox 5"/>
           <p:cNvSpPr txBox="1"/>
           <p:nvPr/>
         </p:nvSpPr>
         <p:spPr>
           <a:xfrm>
-            <a:off x="868680" y="2148840"/>
-            <a:ext cx="5212080" cy="365760"/>
+            <a:off x="1463040" y="2093976"/>
+            <a:ext cx="10058400" cy="822960"/>
           </a:xfrm>
           <a:prstGeom prst="rect">
             <a:avLst/>
@@ -3591,36 +3655,121 @@
           <a:p>
             <a:pPr algn="l">
               <a:lnSpc>
-                <a:spcPct val="112000"/>
-              </a:lnSpc>
-              <a:spcAft>
-                <a:spcPts val="600"/>
-              </a:spcAft>
-            </a:pPr>
-            <a:r>
-              <a:rPr sz="1200" b="1">
-                <a:solidFill>
-                  <a:srgbClr val="F2B8B8"/>
-                </a:solidFill>
-                <a:latin typeface="Inter"/>
-                <a:ea typeface="Inter"/>
-                <a:cs typeface="Inter"/>
-              </a:rPr>
-              <a:t>BEFORE</a:t>
-            </a:r>
-          </a:p>
-        </p:txBody>
-      </p:sp>
-      <p:sp>
-        <p:nvSpPr>
-          <p:cNvPr id="6" name="TextBox 5"/>
+                <a:spcPct val="114000"/>
+              </a:lnSpc>
+              <a:spcAft>
+                <a:spcPts val="200"/>
+              </a:spcAft>
+            </a:pPr>
+            <a:r>
+              <a:rPr sz="1450" b="1">
+                <a:solidFill>
+                  <a:srgbClr val="FFFFFF"/>
+                </a:solidFill>
+                <a:latin typeface="Inter"/>
+                <a:ea typeface="Inter"/>
+                <a:cs typeface="Inter"/>
+              </a:rPr>
+              <a:t>Every active programme, scored in one pass</a:t>
+            </a:r>
+          </a:p>
+          <a:p>
+            <a:pPr algn="l">
+              <a:lnSpc>
+                <a:spcPct val="114000"/>
+              </a:lnSpc>
+              <a:spcAft>
+                <a:spcPts val="200"/>
+              </a:spcAft>
+            </a:pPr>
+            <a:r>
+              <a:rPr sz="1100" b="0">
+                <a:solidFill>
+                  <a:srgbClr val="B0C8DC"/>
+                </a:solidFill>
+                <a:latin typeface="Inter"/>
+                <a:ea typeface="Inter"/>
+                <a:cs typeface="Inter"/>
+              </a:rPr>
+              <a:t>A profile is checked against all of them at once — nothing a household is eligible for is left unseen.</a:t>
+            </a:r>
+          </a:p>
+        </p:txBody>
+      </p:sp>
+      <p:sp>
+        <p:nvSpPr>
+          <p:cNvPr id="7" name="Rounded Rectangle 6"/>
+          <p:cNvSpPr/>
+          <p:nvPr/>
+        </p:nvSpPr>
+        <p:spPr>
+          <a:xfrm>
+            <a:off x="822960" y="3081528"/>
+            <a:ext cx="457200" cy="457200"/>
+          </a:xfrm>
+          <a:prstGeom prst="roundRect">
+            <a:avLst>
+              <a:gd name="adj" fmla="val 25000"/>
+            </a:avLst>
+          </a:prstGeom>
+          <a:solidFill>
+            <a:srgbClr val="2F7A44"/>
+          </a:solidFill>
+          <a:ln>
+            <a:noFill/>
+          </a:ln>
+          <a:effectLst/>
+        </p:spPr>
+        <p:style>
+          <a:lnRef idx="1">
+            <a:schemeClr val="accent1"/>
+          </a:lnRef>
+          <a:fillRef idx="3">
+            <a:schemeClr val="accent1"/>
+          </a:fillRef>
+          <a:effectRef idx="2">
+            <a:schemeClr val="accent1"/>
+          </a:effectRef>
+          <a:fontRef idx="minor">
+            <a:schemeClr val="lt1"/>
+          </a:fontRef>
+        </p:style>
+        <p:txBody>
+          <a:bodyPr rtlCol="0" anchor="ctr" wrap="square" lIns="164592" rIns="164592" tIns="146304" bIns="146304"/>
+          <a:lstStyle/>
+          <a:p>
+            <a:pPr algn="ctr">
+              <a:lnSpc>
+                <a:spcPct val="110000"/>
+              </a:lnSpc>
+              <a:spcAft>
+                <a:spcPts val="300"/>
+              </a:spcAft>
+            </a:pPr>
+            <a:r>
+              <a:rPr sz="2000" b="1">
+                <a:solidFill>
+                  <a:srgbClr val="FFFFFF"/>
+                </a:solidFill>
+                <a:latin typeface="Inter"/>
+                <a:ea typeface="Inter"/>
+                <a:cs typeface="Inter"/>
+              </a:rPr>
+              <a:t>+</a:t>
+            </a:r>
+          </a:p>
+        </p:txBody>
+      </p:sp>
+      <p:sp>
+        <p:nvSpPr>
+          <p:cNvPr id="8" name="TextBox 7"/>
           <p:cNvSpPr txBox="1"/>
           <p:nvPr/>
         </p:nvSpPr>
         <p:spPr>
           <a:xfrm>
-            <a:off x="6400800" y="2148840"/>
-            <a:ext cx="5029200" cy="365760"/>
+            <a:off x="1463040" y="3026664"/>
+            <a:ext cx="10058400" cy="822960"/>
           </a:xfrm>
           <a:prstGeom prst="rect">
             <a:avLst/>
@@ -3635,36 +3784,121 @@
           <a:p>
             <a:pPr algn="l">
               <a:lnSpc>
-                <a:spcPct val="112000"/>
-              </a:lnSpc>
-              <a:spcAft>
-                <a:spcPts val="600"/>
-              </a:spcAft>
-            </a:pPr>
-            <a:r>
-              <a:rPr sz="1200" b="1">
-                <a:solidFill>
-                  <a:srgbClr val="B6E09C"/>
-                </a:solidFill>
-                <a:latin typeface="Inter"/>
-                <a:ea typeface="Inter"/>
-                <a:cs typeface="Inter"/>
-              </a:rPr>
-              <a:t>WITH MUSTAHIQ AI</a:t>
-            </a:r>
-          </a:p>
-        </p:txBody>
-      </p:sp>
-      <p:sp>
-        <p:nvSpPr>
-          <p:cNvPr id="7" name="TextBox 6"/>
+                <a:spcPct val="114000"/>
+              </a:lnSpc>
+              <a:spcAft>
+                <a:spcPts val="200"/>
+              </a:spcAft>
+            </a:pPr>
+            <a:r>
+              <a:rPr sz="1450" b="1">
+                <a:solidFill>
+                  <a:srgbClr val="FFFFFF"/>
+                </a:solidFill>
+                <a:latin typeface="Inter"/>
+                <a:ea typeface="Inter"/>
+                <a:cs typeface="Inter"/>
+              </a:rPr>
+              <a:t>One rubric, applied identically — and snapshotted</a:t>
+            </a:r>
+          </a:p>
+          <a:p>
+            <a:pPr algn="l">
+              <a:lnSpc>
+                <a:spcPct val="114000"/>
+              </a:lnSpc>
+              <a:spcAft>
+                <a:spcPts val="200"/>
+              </a:spcAft>
+            </a:pPr>
+            <a:r>
+              <a:rPr sz="1100" b="0">
+                <a:solidFill>
+                  <a:srgbClr val="B0C8DC"/>
+                </a:solidFill>
+                <a:latin typeface="Inter"/>
+                <a:ea typeface="Inter"/>
+                <a:cs typeface="Inter"/>
+              </a:rPr>
+              <a:t>The same weighted factors for everyone in a cycle; the exact weights are saved with the results.</a:t>
+            </a:r>
+          </a:p>
+        </p:txBody>
+      </p:sp>
+      <p:sp>
+        <p:nvSpPr>
+          <p:cNvPr id="9" name="Rounded Rectangle 8"/>
+          <p:cNvSpPr/>
+          <p:nvPr/>
+        </p:nvSpPr>
+        <p:spPr>
+          <a:xfrm>
+            <a:off x="822960" y="4014216"/>
+            <a:ext cx="457200" cy="457200"/>
+          </a:xfrm>
+          <a:prstGeom prst="roundRect">
+            <a:avLst>
+              <a:gd name="adj" fmla="val 25000"/>
+            </a:avLst>
+          </a:prstGeom>
+          <a:solidFill>
+            <a:srgbClr val="2F7A44"/>
+          </a:solidFill>
+          <a:ln>
+            <a:noFill/>
+          </a:ln>
+          <a:effectLst/>
+        </p:spPr>
+        <p:style>
+          <a:lnRef idx="1">
+            <a:schemeClr val="accent1"/>
+          </a:lnRef>
+          <a:fillRef idx="3">
+            <a:schemeClr val="accent1"/>
+          </a:fillRef>
+          <a:effectRef idx="2">
+            <a:schemeClr val="accent1"/>
+          </a:effectRef>
+          <a:fontRef idx="minor">
+            <a:schemeClr val="lt1"/>
+          </a:fontRef>
+        </p:style>
+        <p:txBody>
+          <a:bodyPr rtlCol="0" anchor="ctr" wrap="square" lIns="164592" rIns="164592" tIns="146304" bIns="146304"/>
+          <a:lstStyle/>
+          <a:p>
+            <a:pPr algn="ctr">
+              <a:lnSpc>
+                <a:spcPct val="110000"/>
+              </a:lnSpc>
+              <a:spcAft>
+                <a:spcPts val="300"/>
+              </a:spcAft>
+            </a:pPr>
+            <a:r>
+              <a:rPr sz="2000" b="1">
+                <a:solidFill>
+                  <a:srgbClr val="FFFFFF"/>
+                </a:solidFill>
+                <a:latin typeface="Inter"/>
+                <a:ea typeface="Inter"/>
+                <a:cs typeface="Inter"/>
+              </a:rPr>
+              <a:t>+</a:t>
+            </a:r>
+          </a:p>
+        </p:txBody>
+      </p:sp>
+      <p:sp>
+        <p:nvSpPr>
+          <p:cNvPr id="10" name="TextBox 9"/>
           <p:cNvSpPr txBox="1"/>
           <p:nvPr/>
         </p:nvSpPr>
         <p:spPr>
           <a:xfrm>
-            <a:off x="868680" y="2651760"/>
-            <a:ext cx="5120640" cy="731520"/>
+            <a:off x="1463040" y="3959352"/>
+            <a:ext cx="10058400" cy="822960"/>
           </a:xfrm>
           <a:prstGeom prst="rect">
             <a:avLst/>
@@ -3679,36 +3913,121 @@
           <a:p>
             <a:pPr algn="l">
               <a:lnSpc>
-                <a:spcPct val="112000"/>
-              </a:lnSpc>
-              <a:spcAft>
-                <a:spcPts val="600"/>
-              </a:spcAft>
-            </a:pPr>
-            <a:r>
-              <a:rPr sz="1200" b="0">
-                <a:solidFill>
-                  <a:srgbClr val="C7DDEF"/>
-                </a:solidFill>
-                <a:latin typeface="Inter"/>
-                <a:ea typeface="Inter"/>
-                <a:cs typeface="Inter"/>
-              </a:rPr>
-              <a:t>One programme checked per visit</a:t>
-            </a:r>
-          </a:p>
-        </p:txBody>
-      </p:sp>
-      <p:sp>
-        <p:nvSpPr>
-          <p:cNvPr id="8" name="TextBox 7"/>
+                <a:spcPct val="114000"/>
+              </a:lnSpc>
+              <a:spcAft>
+                <a:spcPts val="200"/>
+              </a:spcAft>
+            </a:pPr>
+            <a:r>
+              <a:rPr sz="1450" b="1">
+                <a:solidFill>
+                  <a:srgbClr val="FFFFFF"/>
+                </a:solidFill>
+                <a:latin typeface="Inter"/>
+                <a:ea typeface="Inter"/>
+                <a:cs typeface="Inter"/>
+              </a:rPr>
+              <a:t>A plain-language reason on every suggestion and every rank</a:t>
+            </a:r>
+          </a:p>
+          <a:p>
+            <a:pPr algn="l">
+              <a:lnSpc>
+                <a:spcPct val="114000"/>
+              </a:lnSpc>
+              <a:spcAft>
+                <a:spcPts val="200"/>
+              </a:spcAft>
+            </a:pPr>
+            <a:r>
+              <a:rPr sz="1100" b="0">
+                <a:solidFill>
+                  <a:srgbClr val="B0C8DC"/>
+                </a:solidFill>
+                <a:latin typeface="Inter"/>
+                <a:ea typeface="Inter"/>
+                <a:cs typeface="Inter"/>
+              </a:rPr>
+              <a:t>Traceable to the policy passage it came from — a caseworker can read it aloud.</a:t>
+            </a:r>
+          </a:p>
+        </p:txBody>
+      </p:sp>
+      <p:sp>
+        <p:nvSpPr>
+          <p:cNvPr id="11" name="Rounded Rectangle 10"/>
+          <p:cNvSpPr/>
+          <p:nvPr/>
+        </p:nvSpPr>
+        <p:spPr>
+          <a:xfrm>
+            <a:off x="822960" y="4946904"/>
+            <a:ext cx="457200" cy="457200"/>
+          </a:xfrm>
+          <a:prstGeom prst="roundRect">
+            <a:avLst>
+              <a:gd name="adj" fmla="val 25000"/>
+            </a:avLst>
+          </a:prstGeom>
+          <a:solidFill>
+            <a:srgbClr val="2F7A44"/>
+          </a:solidFill>
+          <a:ln>
+            <a:noFill/>
+          </a:ln>
+          <a:effectLst/>
+        </p:spPr>
+        <p:style>
+          <a:lnRef idx="1">
+            <a:schemeClr val="accent1"/>
+          </a:lnRef>
+          <a:fillRef idx="3">
+            <a:schemeClr val="accent1"/>
+          </a:fillRef>
+          <a:effectRef idx="2">
+            <a:schemeClr val="accent1"/>
+          </a:effectRef>
+          <a:fontRef idx="minor">
+            <a:schemeClr val="lt1"/>
+          </a:fontRef>
+        </p:style>
+        <p:txBody>
+          <a:bodyPr rtlCol="0" anchor="ctr" wrap="square" lIns="164592" rIns="164592" tIns="146304" bIns="146304"/>
+          <a:lstStyle/>
+          <a:p>
+            <a:pPr algn="ctr">
+              <a:lnSpc>
+                <a:spcPct val="110000"/>
+              </a:lnSpc>
+              <a:spcAft>
+                <a:spcPts val="300"/>
+              </a:spcAft>
+            </a:pPr>
+            <a:r>
+              <a:rPr sz="2000" b="1">
+                <a:solidFill>
+                  <a:srgbClr val="FFFFFF"/>
+                </a:solidFill>
+                <a:latin typeface="Inter"/>
+                <a:ea typeface="Inter"/>
+                <a:cs typeface="Inter"/>
+              </a:rPr>
+              <a:t>+</a:t>
+            </a:r>
+          </a:p>
+        </p:txBody>
+      </p:sp>
+      <p:sp>
+        <p:nvSpPr>
+          <p:cNvPr id="12" name="TextBox 11"/>
           <p:cNvSpPr txBox="1"/>
           <p:nvPr/>
         </p:nvSpPr>
         <p:spPr>
           <a:xfrm>
-            <a:off x="6400800" y="2651760"/>
-            <a:ext cx="4937760" cy="731520"/>
+            <a:off x="1463040" y="4892040"/>
+            <a:ext cx="10058400" cy="822960"/>
           </a:xfrm>
           <a:prstGeom prst="rect">
             <a:avLst/>
@@ -3723,14 +4042,14 @@
           <a:p>
             <a:pPr algn="l">
               <a:lnSpc>
-                <a:spcPct val="112000"/>
-              </a:lnSpc>
-              <a:spcAft>
-                <a:spcPts val="600"/>
-              </a:spcAft>
-            </a:pPr>
-            <a:r>
-              <a:rPr sz="1200" b="1">
+                <a:spcPct val="114000"/>
+              </a:lnSpc>
+              <a:spcAft>
+                <a:spcPts val="200"/>
+              </a:spcAft>
+            </a:pPr>
+            <a:r>
+              <a:rPr sz="1450" b="1">
                 <a:solidFill>
                   <a:srgbClr val="FFFFFF"/>
                 </a:solidFill>
@@ -3738,21 +4057,42 @@
                 <a:ea typeface="Inter"/>
                 <a:cs typeface="Inter"/>
               </a:rPr>
-              <a:t>Every active programme, in milliseconds</a:t>
-            </a:r>
-          </a:p>
-        </p:txBody>
-      </p:sp>
-      <p:sp>
-        <p:nvSpPr>
-          <p:cNvPr id="9" name="TextBox 8"/>
+              <a:t>A bridge from the loan into a working network</a:t>
+            </a:r>
+          </a:p>
+          <a:p>
+            <a:pPr algn="l">
+              <a:lnSpc>
+                <a:spcPct val="114000"/>
+              </a:lnSpc>
+              <a:spcAft>
+                <a:spcPts val="200"/>
+              </a:spcAft>
+            </a:pPr>
+            <a:r>
+              <a:rPr sz="1100" b="0">
+                <a:solidFill>
+                  <a:srgbClr val="B0C8DC"/>
+                </a:solidFill>
+                <a:latin typeface="Inter"/>
+                <a:ea typeface="Inter"/>
+                <a:cs typeface="Inter"/>
+              </a:rPr>
+              <a:t>Financed businesses matched to nearby suppliers, customers, workers or partners — at no cost.</a:t>
+            </a:r>
+          </a:p>
+        </p:txBody>
+      </p:sp>
+      <p:sp>
+        <p:nvSpPr>
+          <p:cNvPr id="13" name="TextBox 12"/>
           <p:cNvSpPr txBox="1"/>
           <p:nvPr/>
         </p:nvSpPr>
         <p:spPr>
           <a:xfrm>
-            <a:off x="868680" y="3493008"/>
-            <a:ext cx="5120640" cy="731520"/>
+            <a:off x="841248" y="6053328"/>
+            <a:ext cx="10515600" cy="365760"/>
           </a:xfrm>
           <a:prstGeom prst="rect">
             <a:avLst/>
@@ -3774,279 +4114,15 @@
               </a:spcAft>
             </a:pPr>
             <a:r>
-              <a:rPr sz="1200" b="0">
-                <a:solidFill>
-                  <a:srgbClr val="C7DDEF"/>
-                </a:solidFill>
-                <a:latin typeface="Inter"/>
-                <a:ea typeface="Inter"/>
-                <a:cs typeface="Inter"/>
-              </a:rPr>
-              <a:t>Prioritisation by memory &amp; spreadsheet</a:t>
-            </a:r>
-          </a:p>
-        </p:txBody>
-      </p:sp>
-      <p:sp>
-        <p:nvSpPr>
-          <p:cNvPr id="10" name="TextBox 9"/>
-          <p:cNvSpPr txBox="1"/>
-          <p:nvPr/>
-        </p:nvSpPr>
-        <p:spPr>
-          <a:xfrm>
-            <a:off x="6400800" y="3493008"/>
-            <a:ext cx="4937760" cy="731520"/>
-          </a:xfrm>
-          <a:prstGeom prst="rect">
-            <a:avLst/>
-          </a:prstGeom>
-          <a:noFill/>
-        </p:spPr>
-        <p:txBody>
-          <a:bodyPr wrap="square" anchor="t">
-            <a:spAutoFit/>
-          </a:bodyPr>
-          <a:lstStyle/>
-          <a:p>
-            <a:pPr algn="l">
-              <a:lnSpc>
-                <a:spcPct val="112000"/>
-              </a:lnSpc>
-              <a:spcAft>
-                <a:spcPts val="600"/>
-              </a:spcAft>
-            </a:pPr>
-            <a:r>
-              <a:rPr sz="1200" b="1">
-                <a:solidFill>
-                  <a:srgbClr val="FFFFFF"/>
-                </a:solidFill>
-                <a:latin typeface="Inter"/>
-                <a:ea typeface="Inter"/>
-                <a:cs typeface="Inter"/>
-              </a:rPr>
-              <a:t>One rubric, snapshotted, factor-by-factor</a:t>
-            </a:r>
-          </a:p>
-        </p:txBody>
-      </p:sp>
-      <p:sp>
-        <p:nvSpPr>
-          <p:cNvPr id="11" name="TextBox 10"/>
-          <p:cNvSpPr txBox="1"/>
-          <p:nvPr/>
-        </p:nvSpPr>
-        <p:spPr>
-          <a:xfrm>
-            <a:off x="868680" y="4334256"/>
-            <a:ext cx="5120640" cy="731520"/>
-          </a:xfrm>
-          <a:prstGeom prst="rect">
-            <a:avLst/>
-          </a:prstGeom>
-          <a:noFill/>
-        </p:spPr>
-        <p:txBody>
-          <a:bodyPr wrap="square" anchor="t">
-            <a:spAutoFit/>
-          </a:bodyPr>
-          <a:lstStyle/>
-          <a:p>
-            <a:pPr algn="l">
-              <a:lnSpc>
-                <a:spcPct val="112000"/>
-              </a:lnSpc>
-              <a:spcAft>
-                <a:spcPts val="600"/>
-              </a:spcAft>
-            </a:pPr>
-            <a:r>
-              <a:rPr sz="1200" b="0">
-                <a:solidFill>
-                  <a:srgbClr val="C7DDEF"/>
-                </a:solidFill>
-                <a:latin typeface="Inter"/>
-                <a:ea typeface="Inter"/>
-                <a:cs typeface="Inter"/>
-              </a:rPr>
-              <a:t>“Why them?” — no record</a:t>
-            </a:r>
-          </a:p>
-        </p:txBody>
-      </p:sp>
-      <p:sp>
-        <p:nvSpPr>
-          <p:cNvPr id="12" name="TextBox 11"/>
-          <p:cNvSpPr txBox="1"/>
-          <p:nvPr/>
-        </p:nvSpPr>
-        <p:spPr>
-          <a:xfrm>
-            <a:off x="6400800" y="4334256"/>
-            <a:ext cx="4937760" cy="731520"/>
-          </a:xfrm>
-          <a:prstGeom prst="rect">
-            <a:avLst/>
-          </a:prstGeom>
-          <a:noFill/>
-        </p:spPr>
-        <p:txBody>
-          <a:bodyPr wrap="square" anchor="t">
-            <a:spAutoFit/>
-          </a:bodyPr>
-          <a:lstStyle/>
-          <a:p>
-            <a:pPr algn="l">
-              <a:lnSpc>
-                <a:spcPct val="112000"/>
-              </a:lnSpc>
-              <a:spcAft>
-                <a:spcPts val="600"/>
-              </a:spcAft>
-            </a:pPr>
-            <a:r>
-              <a:rPr sz="1200" b="1">
-                <a:solidFill>
-                  <a:srgbClr val="FFFFFF"/>
-                </a:solidFill>
-                <a:latin typeface="Inter"/>
-                <a:ea typeface="Inter"/>
-                <a:cs typeface="Inter"/>
-              </a:rPr>
-              <a:t>A plain-language reason for every decision</a:t>
-            </a:r>
-          </a:p>
-        </p:txBody>
-      </p:sp>
-      <p:sp>
-        <p:nvSpPr>
-          <p:cNvPr id="13" name="TextBox 12"/>
-          <p:cNvSpPr txBox="1"/>
-          <p:nvPr/>
-        </p:nvSpPr>
-        <p:spPr>
-          <a:xfrm>
-            <a:off x="868680" y="5175504"/>
-            <a:ext cx="5120640" cy="731520"/>
-          </a:xfrm>
-          <a:prstGeom prst="rect">
-            <a:avLst/>
-          </a:prstGeom>
-          <a:noFill/>
-        </p:spPr>
-        <p:txBody>
-          <a:bodyPr wrap="square" anchor="t">
-            <a:spAutoFit/>
-          </a:bodyPr>
-          <a:lstStyle/>
-          <a:p>
-            <a:pPr algn="l">
-              <a:lnSpc>
-                <a:spcPct val="112000"/>
-              </a:lnSpc>
-              <a:spcAft>
-                <a:spcPts val="600"/>
-              </a:spcAft>
-            </a:pPr>
-            <a:r>
-              <a:rPr sz="1200" b="0">
-                <a:solidFill>
-                  <a:srgbClr val="C7DDEF"/>
-                </a:solidFill>
-                <a:latin typeface="Inter"/>
-                <a:ea typeface="Inter"/>
-                <a:cs typeface="Inter"/>
-              </a:rPr>
-              <a:t>Loan ends, beneficiary alone</a:t>
-            </a:r>
-          </a:p>
-        </p:txBody>
-      </p:sp>
-      <p:sp>
-        <p:nvSpPr>
-          <p:cNvPr id="14" name="TextBox 13"/>
-          <p:cNvSpPr txBox="1"/>
-          <p:nvPr/>
-        </p:nvSpPr>
-        <p:spPr>
-          <a:xfrm>
-            <a:off x="6400800" y="5175504"/>
-            <a:ext cx="4937760" cy="731520"/>
-          </a:xfrm>
-          <a:prstGeom prst="rect">
-            <a:avLst/>
-          </a:prstGeom>
-          <a:noFill/>
-        </p:spPr>
-        <p:txBody>
-          <a:bodyPr wrap="square" anchor="t">
-            <a:spAutoFit/>
-          </a:bodyPr>
-          <a:lstStyle/>
-          <a:p>
-            <a:pPr algn="l">
-              <a:lnSpc>
-                <a:spcPct val="112000"/>
-              </a:lnSpc>
-              <a:spcAft>
-                <a:spcPts val="600"/>
-              </a:spcAft>
-            </a:pPr>
-            <a:r>
-              <a:rPr sz="1200" b="1">
-                <a:solidFill>
-                  <a:srgbClr val="FFFFFF"/>
-                </a:solidFill>
-                <a:latin typeface="Inter"/>
-                <a:ea typeface="Inter"/>
-                <a:cs typeface="Inter"/>
-              </a:rPr>
-              <a:t>Matched to a network that keeps their business going</a:t>
-            </a:r>
-          </a:p>
-        </p:txBody>
-      </p:sp>
-      <p:sp>
-        <p:nvSpPr>
-          <p:cNvPr id="15" name="TextBox 14"/>
-          <p:cNvSpPr txBox="1"/>
-          <p:nvPr/>
-        </p:nvSpPr>
-        <p:spPr>
-          <a:xfrm>
-            <a:off x="841248" y="6126480"/>
-            <a:ext cx="10515600" cy="365760"/>
-          </a:xfrm>
-          <a:prstGeom prst="rect">
-            <a:avLst/>
-          </a:prstGeom>
-          <a:noFill/>
-        </p:spPr>
-        <p:txBody>
-          <a:bodyPr wrap="square" anchor="t">
-            <a:spAutoFit/>
-          </a:bodyPr>
-          <a:lstStyle/>
-          <a:p>
-            <a:pPr algn="l">
-              <a:lnSpc>
-                <a:spcPct val="112000"/>
-              </a:lnSpc>
-              <a:spcAft>
-                <a:spcPts val="600"/>
-              </a:spcAft>
-            </a:pPr>
-            <a:r>
-              <a:rPr sz="1000" b="0">
-                <a:solidFill>
-                  <a:srgbClr val="9FBAD2"/>
-                </a:solidFill>
-                <a:latin typeface="Inter"/>
-                <a:ea typeface="Inter"/>
-                <a:cs typeface="Inter"/>
-              </a:rPr>
-              <a:t>Roadmap: real verification data → model retraining loop · row-level security · production auth &amp; payments</a:t>
+              <a:rPr sz="1100" b="1">
+                <a:solidFill>
+                  <a:srgbClr val="87BDF0"/>
+                </a:solidFill>
+                <a:latin typeface="Inter"/>
+                <a:ea typeface="Inter"/>
+                <a:cs typeface="Inter"/>
+              </a:rPr>
+              <a:t>It informs the decision — it does not make it. Staff verify, staff rank-review, staff allocate.</a:t>
             </a:r>
           </a:p>
         </p:txBody>
@@ -4196,7 +4272,7 @@
                 <a:ea typeface="Poppins"/>
                 <a:cs typeface="Poppins"/>
               </a:rPr>
-              <a:t>From aid, to auditable aid,</a:t>
+              <a:t>Clearer decisions,</a:t>
             </a:r>
           </a:p>
         </p:txBody>
@@ -4240,7 +4316,7 @@
                 <a:ea typeface="Poppins"/>
                 <a:cs typeface="Poppins"/>
               </a:rPr>
-              <a:t>to self-reliance.</a:t>
+              <a:t>a bridge to self-reliance.</a:t>
             </a:r>
           </a:p>
         </p:txBody>
@@ -4566,20 +4642,64 @@
                 <a:ea typeface="Poppins"/>
                 <a:cs typeface="Poppins"/>
               </a:rPr>
-              <a:t>Deciding who gets limited help is manual — and hard to defend</a:t>
-            </a:r>
-          </a:p>
-        </p:txBody>
-      </p:sp>
-      <p:sp>
-        <p:nvSpPr>
-          <p:cNvPr id="6" name="Rounded Rectangle 5"/>
+              <a:t>Allocating limited aid is a hard problem</a:t>
+            </a:r>
+          </a:p>
+        </p:txBody>
+      </p:sp>
+      <p:sp>
+        <p:nvSpPr>
+          <p:cNvPr id="6" name="TextBox 5"/>
+          <p:cNvSpPr txBox="1"/>
+          <p:nvPr/>
+        </p:nvSpPr>
+        <p:spPr>
+          <a:xfrm>
+            <a:off x="841248" y="1572768"/>
+            <a:ext cx="10424160" cy="548640"/>
+          </a:xfrm>
+          <a:prstGeom prst="rect">
+            <a:avLst/>
+          </a:prstGeom>
+          <a:noFill/>
+        </p:spPr>
+        <p:txBody>
+          <a:bodyPr wrap="square" anchor="t">
+            <a:spAutoFit/>
+          </a:bodyPr>
+          <a:lstStyle/>
+          <a:p>
+            <a:pPr algn="l">
+              <a:lnSpc>
+                <a:spcPct val="112000"/>
+              </a:lnSpc>
+              <a:spcAft>
+                <a:spcPts val="600"/>
+              </a:spcAft>
+            </a:pPr>
+            <a:r>
+              <a:rPr sz="1400" b="0">
+                <a:solidFill>
+                  <a:srgbClr val="738294"/>
+                </a:solidFill>
+                <a:latin typeface="Inter"/>
+                <a:ea typeface="Inter"/>
+                <a:cs typeface="Inter"/>
+              </a:rPr>
+              <a:t>True for any organisation — these questions come with the work, not with any one process.</a:t>
+            </a:r>
+          </a:p>
+        </p:txBody>
+      </p:sp>
+      <p:sp>
+        <p:nvSpPr>
+          <p:cNvPr id="7" name="Rounded Rectangle 6"/>
           <p:cNvSpPr/>
           <p:nvPr/>
         </p:nvSpPr>
         <p:spPr>
           <a:xfrm>
-            <a:off x="822960" y="2148840"/>
+            <a:off x="822960" y="2286000"/>
             <a:ext cx="566928" cy="566928"/>
           </a:xfrm>
           <a:prstGeom prst="roundRect">
@@ -4588,7 +4708,7 @@
             </a:avLst>
           </a:prstGeom>
           <a:solidFill>
-            <a:srgbClr val="FDEAEA"/>
+            <a:srgbClr val="E1EDF8"/>
           </a:solidFill>
           <a:ln>
             <a:noFill/>
@@ -4624,26 +4744,26 @@
             <a:r>
               <a:rPr sz="1900" b="1">
                 <a:solidFill>
-                  <a:srgbClr val="DC0505"/>
-                </a:solidFill>
-                <a:latin typeface="Inter"/>
-                <a:ea typeface="Inter"/>
-                <a:cs typeface="Inter"/>
-              </a:rPr>
-              <a:t>!</a:t>
-            </a:r>
-          </a:p>
-        </p:txBody>
-      </p:sp>
-      <p:sp>
-        <p:nvSpPr>
-          <p:cNvPr id="7" name="TextBox 6"/>
+                  <a:srgbClr val="0060AE"/>
+                </a:solidFill>
+                <a:latin typeface="Inter"/>
+                <a:ea typeface="Inter"/>
+                <a:cs typeface="Inter"/>
+              </a:rPr>
+              <a:t>?</a:t>
+            </a:r>
+          </a:p>
+        </p:txBody>
+      </p:sp>
+      <p:sp>
+        <p:nvSpPr>
+          <p:cNvPr id="8" name="TextBox 7"/>
           <p:cNvSpPr txBox="1"/>
           <p:nvPr/>
         </p:nvSpPr>
         <p:spPr>
           <a:xfrm>
-            <a:off x="1600200" y="2103120"/>
+            <a:off x="1600200" y="2240280"/>
             <a:ext cx="9875520" cy="822960"/>
           </a:xfrm>
           <a:prstGeom prst="rect">
@@ -4674,7 +4794,7 @@
                 <a:ea typeface="Inter"/>
                 <a:cs typeface="Inter"/>
               </a:rPr>
-              <a:t>A household often qualifies for several programmes</a:t>
+              <a:t>Who, among everyone eligible, needs help most right now?</a:t>
             </a:r>
           </a:p>
           <a:p>
@@ -4695,20 +4815,20 @@
                 <a:ea typeface="Inter"/>
                 <a:cs typeface="Inter"/>
               </a:rPr>
-              <a:t>but a field officer only has time to check one or two, so real needs are missed.</a:t>
-            </a:r>
-          </a:p>
-        </p:txBody>
-      </p:sp>
-      <p:sp>
-        <p:nvSpPr>
-          <p:cNvPr id="8" name="Rounded Rectangle 7"/>
+              <a:t>Eligibility is only the first filter. Ranking real need across a whole pool is the harder judgement.</a:t>
+            </a:r>
+          </a:p>
+        </p:txBody>
+      </p:sp>
+      <p:sp>
+        <p:nvSpPr>
+          <p:cNvPr id="9" name="Rounded Rectangle 8"/>
           <p:cNvSpPr/>
           <p:nvPr/>
         </p:nvSpPr>
         <p:spPr>
           <a:xfrm>
-            <a:off x="822960" y="3191256"/>
+            <a:off x="822960" y="3310128"/>
             <a:ext cx="566928" cy="566928"/>
           </a:xfrm>
           <a:prstGeom prst="roundRect">
@@ -4717,7 +4837,7 @@
             </a:avLst>
           </a:prstGeom>
           <a:solidFill>
-            <a:srgbClr val="FDEAEA"/>
+            <a:srgbClr val="E1EDF8"/>
           </a:solidFill>
           <a:ln>
             <a:noFill/>
@@ -4753,26 +4873,26 @@
             <a:r>
               <a:rPr sz="1900" b="1">
                 <a:solidFill>
-                  <a:srgbClr val="DC0505"/>
-                </a:solidFill>
-                <a:latin typeface="Inter"/>
-                <a:ea typeface="Inter"/>
-                <a:cs typeface="Inter"/>
-              </a:rPr>
-              <a:t>!</a:t>
-            </a:r>
-          </a:p>
-        </p:txBody>
-      </p:sp>
-      <p:sp>
-        <p:nvSpPr>
-          <p:cNvPr id="9" name="TextBox 8"/>
+                  <a:srgbClr val="0060AE"/>
+                </a:solidFill>
+                <a:latin typeface="Inter"/>
+                <a:ea typeface="Inter"/>
+                <a:cs typeface="Inter"/>
+              </a:rPr>
+              <a:t>?</a:t>
+            </a:r>
+          </a:p>
+        </p:txBody>
+      </p:sp>
+      <p:sp>
+        <p:nvSpPr>
+          <p:cNvPr id="10" name="TextBox 9"/>
           <p:cNvSpPr txBox="1"/>
           <p:nvPr/>
         </p:nvSpPr>
         <p:spPr>
           <a:xfrm>
-            <a:off x="1600200" y="3145536"/>
+            <a:off x="1600200" y="3264408"/>
             <a:ext cx="9875520" cy="822960"/>
           </a:xfrm>
           <a:prstGeom prst="rect">
@@ -4803,7 +4923,7 @@
                 <a:ea typeface="Inter"/>
                 <a:cs typeface="Inter"/>
               </a:rPr>
-              <a:t>“Why them and not me?” has no clear answer</a:t>
+              <a:t>Can a decision be explained — the same way, every time?</a:t>
             </a:r>
           </a:p>
           <a:p>
@@ -4824,20 +4944,20 @@
                 <a:ea typeface="Inter"/>
                 <a:cs typeface="Inter"/>
               </a:rPr>
-              <a:t>prioritisation lives in spreadsheets and memory; two officers rank the same people differently.</a:t>
-            </a:r>
-          </a:p>
-        </p:txBody>
-      </p:sp>
-      <p:sp>
-        <p:nvSpPr>
-          <p:cNvPr id="10" name="Rounded Rectangle 9"/>
+              <a:t>The person who was not chosen deserves a reason, and two officers should reach the same one.</a:t>
+            </a:r>
+          </a:p>
+        </p:txBody>
+      </p:sp>
+      <p:sp>
+        <p:nvSpPr>
+          <p:cNvPr id="11" name="Rounded Rectangle 10"/>
           <p:cNvSpPr/>
           <p:nvPr/>
         </p:nvSpPr>
         <p:spPr>
           <a:xfrm>
-            <a:off x="822960" y="4233672"/>
+            <a:off x="822960" y="4334256"/>
             <a:ext cx="566928" cy="566928"/>
           </a:xfrm>
           <a:prstGeom prst="roundRect">
@@ -4846,7 +4966,7 @@
             </a:avLst>
           </a:prstGeom>
           <a:solidFill>
-            <a:srgbClr val="FDEAEA"/>
+            <a:srgbClr val="E1EDF8"/>
           </a:solidFill>
           <a:ln>
             <a:noFill/>
@@ -4882,26 +5002,26 @@
             <a:r>
               <a:rPr sz="1900" b="1">
                 <a:solidFill>
-                  <a:srgbClr val="DC0505"/>
-                </a:solidFill>
-                <a:latin typeface="Inter"/>
-                <a:ea typeface="Inter"/>
-                <a:cs typeface="Inter"/>
-              </a:rPr>
-              <a:t>!</a:t>
-            </a:r>
-          </a:p>
-        </p:txBody>
-      </p:sp>
-      <p:sp>
-        <p:nvSpPr>
-          <p:cNvPr id="11" name="TextBox 10"/>
+                  <a:srgbClr val="0060AE"/>
+                </a:solidFill>
+                <a:latin typeface="Inter"/>
+                <a:ea typeface="Inter"/>
+                <a:cs typeface="Inter"/>
+              </a:rPr>
+              <a:t>?</a:t>
+            </a:r>
+          </a:p>
+        </p:txBody>
+      </p:sp>
+      <p:sp>
+        <p:nvSpPr>
+          <p:cNvPr id="12" name="TextBox 11"/>
           <p:cNvSpPr txBox="1"/>
           <p:nvPr/>
         </p:nvSpPr>
         <p:spPr>
           <a:xfrm>
-            <a:off x="1600200" y="4187952"/>
+            <a:off x="1600200" y="4288536"/>
             <a:ext cx="9875520" cy="822960"/>
           </a:xfrm>
           <a:prstGeom prst="rect">
@@ -4932,7 +5052,7 @@
                 <a:ea typeface="Inter"/>
                 <a:cs typeface="Inter"/>
               </a:rPr>
-              <a:t>Verification, waiting lists and budgets are tracked by hand</a:t>
+              <a:t>Does someone qualify for help they never hear about?</a:t>
             </a:r>
           </a:p>
           <a:p>
@@ -4953,20 +5073,20 @@
                 <a:ea typeface="Inter"/>
                 <a:cs typeface="Inter"/>
               </a:rPr>
-              <a:t>across programmes and cycles — slow, and easy to lose.</a:t>
-            </a:r>
-          </a:p>
-        </p:txBody>
-      </p:sp>
-      <p:sp>
-        <p:nvSpPr>
-          <p:cNvPr id="12" name="Rounded Rectangle 11"/>
+              <a:t>A household may be eligible for several programmes and only ever be told about one.</a:t>
+            </a:r>
+          </a:p>
+        </p:txBody>
+      </p:sp>
+      <p:sp>
+        <p:nvSpPr>
+          <p:cNvPr id="13" name="Rounded Rectangle 12"/>
           <p:cNvSpPr/>
           <p:nvPr/>
         </p:nvSpPr>
         <p:spPr>
           <a:xfrm>
-            <a:off x="822960" y="5276088"/>
+            <a:off x="822960" y="5358384"/>
             <a:ext cx="566928" cy="566928"/>
           </a:xfrm>
           <a:prstGeom prst="roundRect">
@@ -4975,7 +5095,7 @@
             </a:avLst>
           </a:prstGeom>
           <a:solidFill>
-            <a:srgbClr val="FDEAEA"/>
+            <a:srgbClr val="E1EDF8"/>
           </a:solidFill>
           <a:ln>
             <a:noFill/>
@@ -5011,26 +5131,26 @@
             <a:r>
               <a:rPr sz="1900" b="1">
                 <a:solidFill>
-                  <a:srgbClr val="DC0505"/>
-                </a:solidFill>
-                <a:latin typeface="Inter"/>
-                <a:ea typeface="Inter"/>
-                <a:cs typeface="Inter"/>
-              </a:rPr>
-              <a:t>!</a:t>
-            </a:r>
-          </a:p>
-        </p:txBody>
-      </p:sp>
-      <p:sp>
-        <p:nvSpPr>
-          <p:cNvPr id="13" name="TextBox 12"/>
+                  <a:srgbClr val="0060AE"/>
+                </a:solidFill>
+                <a:latin typeface="Inter"/>
+                <a:ea typeface="Inter"/>
+                <a:cs typeface="Inter"/>
+              </a:rPr>
+              <a:t>?</a:t>
+            </a:r>
+          </a:p>
+        </p:txBody>
+      </p:sp>
+      <p:sp>
+        <p:nvSpPr>
+          <p:cNvPr id="14" name="TextBox 13"/>
           <p:cNvSpPr txBox="1"/>
           <p:nvPr/>
         </p:nvSpPr>
         <p:spPr>
           <a:xfrm>
-            <a:off x="1600200" y="5230368"/>
+            <a:off x="1600200" y="5312664"/>
             <a:ext cx="9875520" cy="822960"/>
           </a:xfrm>
           <a:prstGeom prst="rect">
@@ -5061,7 +5181,7 @@
                 <a:ea typeface="Inter"/>
                 <a:cs typeface="Inter"/>
               </a:rPr>
-              <a:t>A beneficiary who starts a business is on their own</a:t>
+              <a:t>What keeps a business going after the loan?</a:t>
             </a:r>
           </a:p>
           <a:p>
@@ -5082,14 +5202,14 @@
                 <a:ea typeface="Inter"/>
                 <a:cs typeface="Inter"/>
               </a:rPr>
-              <a:t>the loan ends; nobody connects them to suppliers, customers or partners.</a:t>
-            </a:r>
-          </a:p>
-        </p:txBody>
-      </p:sp>
-      <p:sp>
-        <p:nvSpPr>
-          <p:cNvPr id="14" name="TextBox 13"/>
+              <a:t>A financed micro-business still needs suppliers, customers, workers or partners to survive.</a:t>
+            </a:r>
+          </a:p>
+        </p:txBody>
+      </p:sp>
+      <p:sp>
+        <p:nvSpPr>
+          <p:cNvPr id="15" name="TextBox 14"/>
           <p:cNvSpPr txBox="1"/>
           <p:nvPr/>
         </p:nvSpPr>
@@ -5133,7 +5253,7 @@
       </p:sp>
       <p:sp>
         <p:nvSpPr>
-          <p:cNvPr id="15" name="TextBox 14"/>
+          <p:cNvPr id="16" name="TextBox 15"/>
           <p:cNvSpPr txBox="1"/>
           <p:nvPr/>
         </p:nvSpPr>

</xml_diff>